<commit_message>
Refine interpretations, fix histogram empty-bin handling, and align Q4 redesign figure
</commit_message>
<xml_diff>
--- a/slides/FA24-BEDS-052.pptx
+++ b/slides/FA24-BEDS-052.pptx
@@ -132,7 +132,7 @@
           <p:cNvPr id="2" name="Title 1">
             <a:extLst>
               <a:ext uri="{FF2B5EF4-FFF2-40B4-BE49-F238E27FC236}">
-                <a16:creationId xmlns:a16="http://schemas.microsoft.com/office/drawing/2014/main" id="{DD4D9F35-4946-4D96-A3D5-A99D8D7241B0}"/>
+                <a16:creationId xmlns:a16="http://schemas.microsoft.com/office/drawing/2014/main" id="{BD66E3DD-AF47-4C11-8183-E72C1ACB4454}"/>
               </a:ext>
             </a:extLst>
           </p:cNvPr>
@@ -169,7 +169,7 @@
           <p:cNvPr id="3" name="Subtitle 2">
             <a:extLst>
               <a:ext uri="{FF2B5EF4-FFF2-40B4-BE49-F238E27FC236}">
-                <a16:creationId xmlns:a16="http://schemas.microsoft.com/office/drawing/2014/main" id="{B19D896A-91DA-4255-8CB7-7D6E44FFB75D}"/>
+                <a16:creationId xmlns:a16="http://schemas.microsoft.com/office/drawing/2014/main" id="{A63E0E87-4C1C-4907-93E1-36DE0C2895B2}"/>
               </a:ext>
             </a:extLst>
           </p:cNvPr>
@@ -239,7 +239,7 @@
           <p:cNvPr id="4" name="Date Placeholder 3">
             <a:extLst>
               <a:ext uri="{FF2B5EF4-FFF2-40B4-BE49-F238E27FC236}">
-                <a16:creationId xmlns:a16="http://schemas.microsoft.com/office/drawing/2014/main" id="{6496F87F-8A03-4E36-A47B-920B12AE37E7}"/>
+                <a16:creationId xmlns:a16="http://schemas.microsoft.com/office/drawing/2014/main" id="{42307269-3FE8-4998-92FD-945725FBC6AF}"/>
               </a:ext>
             </a:extLst>
           </p:cNvPr>
@@ -255,9 +255,9 @@
           <a:bodyPr/>
           <a:lstStyle/>
           <a:p>
-            <a:fld id="{68475CE9-0D53-4C49-BA8E-D50EFDE4F01D}" type="datetimeFigureOut">
+            <a:fld id="{0DDFDF14-270D-4278-A887-0FE7C53E2537}" type="datetimeFigureOut">
               <a:rPr lang="en-US" smtClean="0"/>
-              <a:t>10/24/2026</a:t>
+              <a:t>10/25/2026</a:t>
             </a:fld>
             <a:endParaRPr lang="en-US"/>
           </a:p>
@@ -268,7 +268,7 @@
           <p:cNvPr id="5" name="Footer Placeholder 4">
             <a:extLst>
               <a:ext uri="{FF2B5EF4-FFF2-40B4-BE49-F238E27FC236}">
-                <a16:creationId xmlns:a16="http://schemas.microsoft.com/office/drawing/2014/main" id="{AD8219F5-ABD2-4E62-9274-508FEE500E82}"/>
+                <a16:creationId xmlns:a16="http://schemas.microsoft.com/office/drawing/2014/main" id="{4D8B618F-7BC6-4683-9D4F-8FA511DEBAD7}"/>
               </a:ext>
             </a:extLst>
           </p:cNvPr>
@@ -293,7 +293,7 @@
           <p:cNvPr id="6" name="Slide Number Placeholder 5">
             <a:extLst>
               <a:ext uri="{FF2B5EF4-FFF2-40B4-BE49-F238E27FC236}">
-                <a16:creationId xmlns:a16="http://schemas.microsoft.com/office/drawing/2014/main" id="{E4BEA0D4-0BEE-4486-BA0A-407F99E845BE}"/>
+                <a16:creationId xmlns:a16="http://schemas.microsoft.com/office/drawing/2014/main" id="{889142B7-408A-4958-9FE8-37035D630FCE}"/>
               </a:ext>
             </a:extLst>
           </p:cNvPr>
@@ -309,7 +309,7 @@
           <a:bodyPr/>
           <a:lstStyle/>
           <a:p>
-            <a:fld id="{A6DADD06-3029-494A-BD87-B23A2BA0527F}" type="slidenum">
+            <a:fld id="{47A61D63-2B5F-48DC-98FA-4A3658F39B21}" type="slidenum">
               <a:rPr lang="en-US" smtClean="0"/>
               <a:t>‹#›</a:t>
             </a:fld>
@@ -320,7 +320,7 @@
     </p:spTree>
     <p:extLst>
       <p:ext uri="{BB962C8B-B14F-4D97-AF65-F5344CB8AC3E}">
-        <p14:creationId xmlns:p14="http://schemas.microsoft.com/office/powerpoint/2010/main" val="676081324"/>
+        <p14:creationId xmlns:p14="http://schemas.microsoft.com/office/powerpoint/2010/main" val="3246847367"/>
       </p:ext>
     </p:extLst>
   </p:cSld>
@@ -352,7 +352,7 @@
           <p:cNvPr id="2" name="Title 1">
             <a:extLst>
               <a:ext uri="{FF2B5EF4-FFF2-40B4-BE49-F238E27FC236}">
-                <a16:creationId xmlns:a16="http://schemas.microsoft.com/office/drawing/2014/main" id="{6DC7CB5C-39FC-4F7F-9FCB-D68E67E24FD3}"/>
+                <a16:creationId xmlns:a16="http://schemas.microsoft.com/office/drawing/2014/main" id="{DDED33C5-5219-4327-87A1-54930EFABA10}"/>
               </a:ext>
             </a:extLst>
           </p:cNvPr>
@@ -380,7 +380,7 @@
           <p:cNvPr id="3" name="Vertical Text Placeholder 2">
             <a:extLst>
               <a:ext uri="{FF2B5EF4-FFF2-40B4-BE49-F238E27FC236}">
-                <a16:creationId xmlns:a16="http://schemas.microsoft.com/office/drawing/2014/main" id="{EEF9440F-424D-48CC-9C69-1433CC92D599}"/>
+                <a16:creationId xmlns:a16="http://schemas.microsoft.com/office/drawing/2014/main" id="{7B340156-D795-4DC4-9CB2-47D2CCA75D6A}"/>
               </a:ext>
             </a:extLst>
           </p:cNvPr>
@@ -437,7 +437,7 @@
           <p:cNvPr id="4" name="Date Placeholder 3">
             <a:extLst>
               <a:ext uri="{FF2B5EF4-FFF2-40B4-BE49-F238E27FC236}">
-                <a16:creationId xmlns:a16="http://schemas.microsoft.com/office/drawing/2014/main" id="{FF19A672-EB6B-4BAD-95B1-66F31723E6E2}"/>
+                <a16:creationId xmlns:a16="http://schemas.microsoft.com/office/drawing/2014/main" id="{9F1D022B-F861-4C8D-95B6-5672A495E818}"/>
               </a:ext>
             </a:extLst>
           </p:cNvPr>
@@ -453,9 +453,9 @@
           <a:bodyPr/>
           <a:lstStyle/>
           <a:p>
-            <a:fld id="{68475CE9-0D53-4C49-BA8E-D50EFDE4F01D}" type="datetimeFigureOut">
+            <a:fld id="{0DDFDF14-270D-4278-A887-0FE7C53E2537}" type="datetimeFigureOut">
               <a:rPr lang="en-US" smtClean="0"/>
-              <a:t>10/24/2026</a:t>
+              <a:t>10/25/2026</a:t>
             </a:fld>
             <a:endParaRPr lang="en-US"/>
           </a:p>
@@ -466,7 +466,7 @@
           <p:cNvPr id="5" name="Footer Placeholder 4">
             <a:extLst>
               <a:ext uri="{FF2B5EF4-FFF2-40B4-BE49-F238E27FC236}">
-                <a16:creationId xmlns:a16="http://schemas.microsoft.com/office/drawing/2014/main" id="{62CE2A6F-D48A-4551-B933-BAEB495EA826}"/>
+                <a16:creationId xmlns:a16="http://schemas.microsoft.com/office/drawing/2014/main" id="{95CA531C-A080-4049-9746-6CD37A4977BD}"/>
               </a:ext>
             </a:extLst>
           </p:cNvPr>
@@ -491,7 +491,7 @@
           <p:cNvPr id="6" name="Slide Number Placeholder 5">
             <a:extLst>
               <a:ext uri="{FF2B5EF4-FFF2-40B4-BE49-F238E27FC236}">
-                <a16:creationId xmlns:a16="http://schemas.microsoft.com/office/drawing/2014/main" id="{00065C1D-B43D-4066-B154-5C99C56EB456}"/>
+                <a16:creationId xmlns:a16="http://schemas.microsoft.com/office/drawing/2014/main" id="{252ADA09-4BE2-48AE-AA1D-670A9A3194FF}"/>
               </a:ext>
             </a:extLst>
           </p:cNvPr>
@@ -507,7 +507,7 @@
           <a:bodyPr/>
           <a:lstStyle/>
           <a:p>
-            <a:fld id="{A6DADD06-3029-494A-BD87-B23A2BA0527F}" type="slidenum">
+            <a:fld id="{47A61D63-2B5F-48DC-98FA-4A3658F39B21}" type="slidenum">
               <a:rPr lang="en-US" smtClean="0"/>
               <a:t>‹#›</a:t>
             </a:fld>
@@ -518,7 +518,7 @@
     </p:spTree>
     <p:extLst>
       <p:ext uri="{BB962C8B-B14F-4D97-AF65-F5344CB8AC3E}">
-        <p14:creationId xmlns:p14="http://schemas.microsoft.com/office/powerpoint/2010/main" val="3935661019"/>
+        <p14:creationId xmlns:p14="http://schemas.microsoft.com/office/powerpoint/2010/main" val="2636754558"/>
       </p:ext>
     </p:extLst>
   </p:cSld>
@@ -550,7 +550,7 @@
           <p:cNvPr id="2" name="Vertical Title 1">
             <a:extLst>
               <a:ext uri="{FF2B5EF4-FFF2-40B4-BE49-F238E27FC236}">
-                <a16:creationId xmlns:a16="http://schemas.microsoft.com/office/drawing/2014/main" id="{968DF6AD-35E6-419F-BF16-DF33E3BD01F1}"/>
+                <a16:creationId xmlns:a16="http://schemas.microsoft.com/office/drawing/2014/main" id="{071F3720-BA79-4968-89B7-EE9B061E593F}"/>
               </a:ext>
             </a:extLst>
           </p:cNvPr>
@@ -583,7 +583,7 @@
           <p:cNvPr id="3" name="Vertical Text Placeholder 2">
             <a:extLst>
               <a:ext uri="{FF2B5EF4-FFF2-40B4-BE49-F238E27FC236}">
-                <a16:creationId xmlns:a16="http://schemas.microsoft.com/office/drawing/2014/main" id="{A19DEEF7-7781-4054-8416-C236FECB2511}"/>
+                <a16:creationId xmlns:a16="http://schemas.microsoft.com/office/drawing/2014/main" id="{6CE3FFD4-2B34-429D-89A6-3CC371BB4FD5}"/>
               </a:ext>
             </a:extLst>
           </p:cNvPr>
@@ -645,7 +645,7 @@
           <p:cNvPr id="4" name="Date Placeholder 3">
             <a:extLst>
               <a:ext uri="{FF2B5EF4-FFF2-40B4-BE49-F238E27FC236}">
-                <a16:creationId xmlns:a16="http://schemas.microsoft.com/office/drawing/2014/main" id="{543C9275-67C7-47D6-B60B-6F1F54D0785A}"/>
+                <a16:creationId xmlns:a16="http://schemas.microsoft.com/office/drawing/2014/main" id="{5C75A556-1717-4ECA-92FC-0D85A8A4F55A}"/>
               </a:ext>
             </a:extLst>
           </p:cNvPr>
@@ -661,9 +661,9 @@
           <a:bodyPr/>
           <a:lstStyle/>
           <a:p>
-            <a:fld id="{68475CE9-0D53-4C49-BA8E-D50EFDE4F01D}" type="datetimeFigureOut">
+            <a:fld id="{0DDFDF14-270D-4278-A887-0FE7C53E2537}" type="datetimeFigureOut">
               <a:rPr lang="en-US" smtClean="0"/>
-              <a:t>10/24/2026</a:t>
+              <a:t>10/25/2026</a:t>
             </a:fld>
             <a:endParaRPr lang="en-US"/>
           </a:p>
@@ -674,7 +674,7 @@
           <p:cNvPr id="5" name="Footer Placeholder 4">
             <a:extLst>
               <a:ext uri="{FF2B5EF4-FFF2-40B4-BE49-F238E27FC236}">
-                <a16:creationId xmlns:a16="http://schemas.microsoft.com/office/drawing/2014/main" id="{508D053E-D96F-455E-9614-AD204B029ED0}"/>
+                <a16:creationId xmlns:a16="http://schemas.microsoft.com/office/drawing/2014/main" id="{3ABB636B-D1B0-44CF-82B7-3D1A7F8EBFDF}"/>
               </a:ext>
             </a:extLst>
           </p:cNvPr>
@@ -699,7 +699,7 @@
           <p:cNvPr id="6" name="Slide Number Placeholder 5">
             <a:extLst>
               <a:ext uri="{FF2B5EF4-FFF2-40B4-BE49-F238E27FC236}">
-                <a16:creationId xmlns:a16="http://schemas.microsoft.com/office/drawing/2014/main" id="{71001BAF-A594-40E4-89C2-938EAB9E9F83}"/>
+                <a16:creationId xmlns:a16="http://schemas.microsoft.com/office/drawing/2014/main" id="{0EC31867-EEAB-4359-B134-CBE0475020BB}"/>
               </a:ext>
             </a:extLst>
           </p:cNvPr>
@@ -715,7 +715,7 @@
           <a:bodyPr/>
           <a:lstStyle/>
           <a:p>
-            <a:fld id="{A6DADD06-3029-494A-BD87-B23A2BA0527F}" type="slidenum">
+            <a:fld id="{47A61D63-2B5F-48DC-98FA-4A3658F39B21}" type="slidenum">
               <a:rPr lang="en-US" smtClean="0"/>
               <a:t>‹#›</a:t>
             </a:fld>
@@ -726,7 +726,7 @@
     </p:spTree>
     <p:extLst>
       <p:ext uri="{BB962C8B-B14F-4D97-AF65-F5344CB8AC3E}">
-        <p14:creationId xmlns:p14="http://schemas.microsoft.com/office/powerpoint/2010/main" val="3921519891"/>
+        <p14:creationId xmlns:p14="http://schemas.microsoft.com/office/powerpoint/2010/main" val="256134442"/>
       </p:ext>
     </p:extLst>
   </p:cSld>
@@ -758,7 +758,7 @@
           <p:cNvPr id="2" name="Title 1">
             <a:extLst>
               <a:ext uri="{FF2B5EF4-FFF2-40B4-BE49-F238E27FC236}">
-                <a16:creationId xmlns:a16="http://schemas.microsoft.com/office/drawing/2014/main" id="{56DC5220-E615-44EA-912D-71526B0C41C6}"/>
+                <a16:creationId xmlns:a16="http://schemas.microsoft.com/office/drawing/2014/main" id="{C794E3E2-6E69-45DC-9F44-F4FCE2D2A474}"/>
               </a:ext>
             </a:extLst>
           </p:cNvPr>
@@ -786,7 +786,7 @@
           <p:cNvPr id="3" name="Content Placeholder 2">
             <a:extLst>
               <a:ext uri="{FF2B5EF4-FFF2-40B4-BE49-F238E27FC236}">
-                <a16:creationId xmlns:a16="http://schemas.microsoft.com/office/drawing/2014/main" id="{5026D795-0387-4779-80CB-C6D40D849D5E}"/>
+                <a16:creationId xmlns:a16="http://schemas.microsoft.com/office/drawing/2014/main" id="{10306EFD-C9AE-4CC6-A76C-D9181CCCAEA5}"/>
               </a:ext>
             </a:extLst>
           </p:cNvPr>
@@ -843,7 +843,7 @@
           <p:cNvPr id="4" name="Date Placeholder 3">
             <a:extLst>
               <a:ext uri="{FF2B5EF4-FFF2-40B4-BE49-F238E27FC236}">
-                <a16:creationId xmlns:a16="http://schemas.microsoft.com/office/drawing/2014/main" id="{D36D726C-3F92-4B73-BCDA-D17063A32354}"/>
+                <a16:creationId xmlns:a16="http://schemas.microsoft.com/office/drawing/2014/main" id="{40C9009F-3E00-4DBE-B257-635FA39AE126}"/>
               </a:ext>
             </a:extLst>
           </p:cNvPr>
@@ -859,9 +859,9 @@
           <a:bodyPr/>
           <a:lstStyle/>
           <a:p>
-            <a:fld id="{68475CE9-0D53-4C49-BA8E-D50EFDE4F01D}" type="datetimeFigureOut">
+            <a:fld id="{0DDFDF14-270D-4278-A887-0FE7C53E2537}" type="datetimeFigureOut">
               <a:rPr lang="en-US" smtClean="0"/>
-              <a:t>10/24/2026</a:t>
+              <a:t>10/25/2026</a:t>
             </a:fld>
             <a:endParaRPr lang="en-US"/>
           </a:p>
@@ -872,7 +872,7 @@
           <p:cNvPr id="5" name="Footer Placeholder 4">
             <a:extLst>
               <a:ext uri="{FF2B5EF4-FFF2-40B4-BE49-F238E27FC236}">
-                <a16:creationId xmlns:a16="http://schemas.microsoft.com/office/drawing/2014/main" id="{411E23DC-7C22-4442-AF86-E175797D6F38}"/>
+                <a16:creationId xmlns:a16="http://schemas.microsoft.com/office/drawing/2014/main" id="{CC1B6040-6FCB-4CB8-8642-4C13724EFD97}"/>
               </a:ext>
             </a:extLst>
           </p:cNvPr>
@@ -897,7 +897,7 @@
           <p:cNvPr id="6" name="Slide Number Placeholder 5">
             <a:extLst>
               <a:ext uri="{FF2B5EF4-FFF2-40B4-BE49-F238E27FC236}">
-                <a16:creationId xmlns:a16="http://schemas.microsoft.com/office/drawing/2014/main" id="{7C9BAB9B-D1CF-4F4F-AD1F-31FE0F21D455}"/>
+                <a16:creationId xmlns:a16="http://schemas.microsoft.com/office/drawing/2014/main" id="{58975F4E-FABB-4C37-9FA7-F98D1164307E}"/>
               </a:ext>
             </a:extLst>
           </p:cNvPr>
@@ -913,7 +913,7 @@
           <a:bodyPr/>
           <a:lstStyle/>
           <a:p>
-            <a:fld id="{A6DADD06-3029-494A-BD87-B23A2BA0527F}" type="slidenum">
+            <a:fld id="{47A61D63-2B5F-48DC-98FA-4A3658F39B21}" type="slidenum">
               <a:rPr lang="en-US" smtClean="0"/>
               <a:t>‹#›</a:t>
             </a:fld>
@@ -924,7 +924,7 @@
     </p:spTree>
     <p:extLst>
       <p:ext uri="{BB962C8B-B14F-4D97-AF65-F5344CB8AC3E}">
-        <p14:creationId xmlns:p14="http://schemas.microsoft.com/office/powerpoint/2010/main" val="1135455360"/>
+        <p14:creationId xmlns:p14="http://schemas.microsoft.com/office/powerpoint/2010/main" val="1156215248"/>
       </p:ext>
     </p:extLst>
   </p:cSld>
@@ -956,7 +956,7 @@
           <p:cNvPr id="2" name="Title 1">
             <a:extLst>
               <a:ext uri="{FF2B5EF4-FFF2-40B4-BE49-F238E27FC236}">
-                <a16:creationId xmlns:a16="http://schemas.microsoft.com/office/drawing/2014/main" id="{84A79225-92CF-4B84-9DF2-9C670F0326CA}"/>
+                <a16:creationId xmlns:a16="http://schemas.microsoft.com/office/drawing/2014/main" id="{903A003D-6D1E-42D8-8DDF-37990308CF26}"/>
               </a:ext>
             </a:extLst>
           </p:cNvPr>
@@ -993,7 +993,7 @@
           <p:cNvPr id="3" name="Text Placeholder 2">
             <a:extLst>
               <a:ext uri="{FF2B5EF4-FFF2-40B4-BE49-F238E27FC236}">
-                <a16:creationId xmlns:a16="http://schemas.microsoft.com/office/drawing/2014/main" id="{453BCFA5-BAE6-4B25-A30E-C0ACA83DE8C3}"/>
+                <a16:creationId xmlns:a16="http://schemas.microsoft.com/office/drawing/2014/main" id="{3E7F2E47-D2F6-4503-89C5-598C53CDB997}"/>
               </a:ext>
             </a:extLst>
           </p:cNvPr>
@@ -1118,7 +1118,7 @@
           <p:cNvPr id="4" name="Date Placeholder 3">
             <a:extLst>
               <a:ext uri="{FF2B5EF4-FFF2-40B4-BE49-F238E27FC236}">
-                <a16:creationId xmlns:a16="http://schemas.microsoft.com/office/drawing/2014/main" id="{F77B3EEE-57D5-433A-8F6B-2B4EADDD0F85}"/>
+                <a16:creationId xmlns:a16="http://schemas.microsoft.com/office/drawing/2014/main" id="{FE22B00A-2510-411C-8E8B-5387E65B86E2}"/>
               </a:ext>
             </a:extLst>
           </p:cNvPr>
@@ -1134,9 +1134,9 @@
           <a:bodyPr/>
           <a:lstStyle/>
           <a:p>
-            <a:fld id="{68475CE9-0D53-4C49-BA8E-D50EFDE4F01D}" type="datetimeFigureOut">
+            <a:fld id="{0DDFDF14-270D-4278-A887-0FE7C53E2537}" type="datetimeFigureOut">
               <a:rPr lang="en-US" smtClean="0"/>
-              <a:t>10/24/2026</a:t>
+              <a:t>10/25/2026</a:t>
             </a:fld>
             <a:endParaRPr lang="en-US"/>
           </a:p>
@@ -1147,7 +1147,7 @@
           <p:cNvPr id="5" name="Footer Placeholder 4">
             <a:extLst>
               <a:ext uri="{FF2B5EF4-FFF2-40B4-BE49-F238E27FC236}">
-                <a16:creationId xmlns:a16="http://schemas.microsoft.com/office/drawing/2014/main" id="{70819206-F383-4A3C-B2F4-1C739DE26944}"/>
+                <a16:creationId xmlns:a16="http://schemas.microsoft.com/office/drawing/2014/main" id="{085ABE2C-9A85-46C5-8897-7ABCFAD525D5}"/>
               </a:ext>
             </a:extLst>
           </p:cNvPr>
@@ -1172,7 +1172,7 @@
           <p:cNvPr id="6" name="Slide Number Placeholder 5">
             <a:extLst>
               <a:ext uri="{FF2B5EF4-FFF2-40B4-BE49-F238E27FC236}">
-                <a16:creationId xmlns:a16="http://schemas.microsoft.com/office/drawing/2014/main" id="{D9E8AF0E-1DD3-4180-8F19-C107828161FD}"/>
+                <a16:creationId xmlns:a16="http://schemas.microsoft.com/office/drawing/2014/main" id="{7742A4F7-A725-4B75-94DC-A4AB16CFB908}"/>
               </a:ext>
             </a:extLst>
           </p:cNvPr>
@@ -1188,7 +1188,7 @@
           <a:bodyPr/>
           <a:lstStyle/>
           <a:p>
-            <a:fld id="{A6DADD06-3029-494A-BD87-B23A2BA0527F}" type="slidenum">
+            <a:fld id="{47A61D63-2B5F-48DC-98FA-4A3658F39B21}" type="slidenum">
               <a:rPr lang="en-US" smtClean="0"/>
               <a:t>‹#›</a:t>
             </a:fld>
@@ -1199,7 +1199,7 @@
     </p:spTree>
     <p:extLst>
       <p:ext uri="{BB962C8B-B14F-4D97-AF65-F5344CB8AC3E}">
-        <p14:creationId xmlns:p14="http://schemas.microsoft.com/office/powerpoint/2010/main" val="384700546"/>
+        <p14:creationId xmlns:p14="http://schemas.microsoft.com/office/powerpoint/2010/main" val="3482921889"/>
       </p:ext>
     </p:extLst>
   </p:cSld>
@@ -1231,7 +1231,7 @@
           <p:cNvPr id="2" name="Title 1">
             <a:extLst>
               <a:ext uri="{FF2B5EF4-FFF2-40B4-BE49-F238E27FC236}">
-                <a16:creationId xmlns:a16="http://schemas.microsoft.com/office/drawing/2014/main" id="{E2C4AC16-72F7-4C21-8F9B-387A81124D9B}"/>
+                <a16:creationId xmlns:a16="http://schemas.microsoft.com/office/drawing/2014/main" id="{F7F75DCE-1A38-49C2-BC14-BA1779BC1711}"/>
               </a:ext>
             </a:extLst>
           </p:cNvPr>
@@ -1259,7 +1259,7 @@
           <p:cNvPr id="3" name="Content Placeholder 2">
             <a:extLst>
               <a:ext uri="{FF2B5EF4-FFF2-40B4-BE49-F238E27FC236}">
-                <a16:creationId xmlns:a16="http://schemas.microsoft.com/office/drawing/2014/main" id="{6CEF8890-00EB-422D-8A8F-F9212DA3AC75}"/>
+                <a16:creationId xmlns:a16="http://schemas.microsoft.com/office/drawing/2014/main" id="{F338C827-9AF4-4A86-AF22-B275190BE9DE}"/>
               </a:ext>
             </a:extLst>
           </p:cNvPr>
@@ -1321,7 +1321,7 @@
           <p:cNvPr id="4" name="Content Placeholder 3">
             <a:extLst>
               <a:ext uri="{FF2B5EF4-FFF2-40B4-BE49-F238E27FC236}">
-                <a16:creationId xmlns:a16="http://schemas.microsoft.com/office/drawing/2014/main" id="{5302ED4A-5C41-4E2C-81A9-11B439133494}"/>
+                <a16:creationId xmlns:a16="http://schemas.microsoft.com/office/drawing/2014/main" id="{7F378806-F5E4-4683-8834-00B9EF719F94}"/>
               </a:ext>
             </a:extLst>
           </p:cNvPr>
@@ -1383,7 +1383,7 @@
           <p:cNvPr id="5" name="Date Placeholder 4">
             <a:extLst>
               <a:ext uri="{FF2B5EF4-FFF2-40B4-BE49-F238E27FC236}">
-                <a16:creationId xmlns:a16="http://schemas.microsoft.com/office/drawing/2014/main" id="{26743E56-720F-4DA6-8A16-35AF19031D14}"/>
+                <a16:creationId xmlns:a16="http://schemas.microsoft.com/office/drawing/2014/main" id="{CE611D3B-4F76-4B35-8213-ECF05DD5EF17}"/>
               </a:ext>
             </a:extLst>
           </p:cNvPr>
@@ -1399,9 +1399,9 @@
           <a:bodyPr/>
           <a:lstStyle/>
           <a:p>
-            <a:fld id="{68475CE9-0D53-4C49-BA8E-D50EFDE4F01D}" type="datetimeFigureOut">
+            <a:fld id="{0DDFDF14-270D-4278-A887-0FE7C53E2537}" type="datetimeFigureOut">
               <a:rPr lang="en-US" smtClean="0"/>
-              <a:t>10/24/2026</a:t>
+              <a:t>10/25/2026</a:t>
             </a:fld>
             <a:endParaRPr lang="en-US"/>
           </a:p>
@@ -1412,7 +1412,7 @@
           <p:cNvPr id="6" name="Footer Placeholder 5">
             <a:extLst>
               <a:ext uri="{FF2B5EF4-FFF2-40B4-BE49-F238E27FC236}">
-                <a16:creationId xmlns:a16="http://schemas.microsoft.com/office/drawing/2014/main" id="{E5076FE5-0735-4C62-B780-6BF545D26EA6}"/>
+                <a16:creationId xmlns:a16="http://schemas.microsoft.com/office/drawing/2014/main" id="{3DA804F4-DAB8-4BF0-A357-3434A2454E2E}"/>
               </a:ext>
             </a:extLst>
           </p:cNvPr>
@@ -1437,7 +1437,7 @@
           <p:cNvPr id="7" name="Slide Number Placeholder 6">
             <a:extLst>
               <a:ext uri="{FF2B5EF4-FFF2-40B4-BE49-F238E27FC236}">
-                <a16:creationId xmlns:a16="http://schemas.microsoft.com/office/drawing/2014/main" id="{10169147-2899-4689-9260-CDA8308E4AB6}"/>
+                <a16:creationId xmlns:a16="http://schemas.microsoft.com/office/drawing/2014/main" id="{69785870-ADA1-41D0-BFC6-059392A239C9}"/>
               </a:ext>
             </a:extLst>
           </p:cNvPr>
@@ -1453,7 +1453,7 @@
           <a:bodyPr/>
           <a:lstStyle/>
           <a:p>
-            <a:fld id="{A6DADD06-3029-494A-BD87-B23A2BA0527F}" type="slidenum">
+            <a:fld id="{47A61D63-2B5F-48DC-98FA-4A3658F39B21}" type="slidenum">
               <a:rPr lang="en-US" smtClean="0"/>
               <a:t>‹#›</a:t>
             </a:fld>
@@ -1464,7 +1464,7 @@
     </p:spTree>
     <p:extLst>
       <p:ext uri="{BB962C8B-B14F-4D97-AF65-F5344CB8AC3E}">
-        <p14:creationId xmlns:p14="http://schemas.microsoft.com/office/powerpoint/2010/main" val="1248501407"/>
+        <p14:creationId xmlns:p14="http://schemas.microsoft.com/office/powerpoint/2010/main" val="2311611965"/>
       </p:ext>
     </p:extLst>
   </p:cSld>
@@ -1496,7 +1496,7 @@
           <p:cNvPr id="2" name="Title 1">
             <a:extLst>
               <a:ext uri="{FF2B5EF4-FFF2-40B4-BE49-F238E27FC236}">
-                <a16:creationId xmlns:a16="http://schemas.microsoft.com/office/drawing/2014/main" id="{6C20F565-C028-498C-99BF-B40D3573A2CB}"/>
+                <a16:creationId xmlns:a16="http://schemas.microsoft.com/office/drawing/2014/main" id="{8AC0223D-EBBE-4C32-B82D-761FA8125C79}"/>
               </a:ext>
             </a:extLst>
           </p:cNvPr>
@@ -1529,7 +1529,7 @@
           <p:cNvPr id="3" name="Text Placeholder 2">
             <a:extLst>
               <a:ext uri="{FF2B5EF4-FFF2-40B4-BE49-F238E27FC236}">
-                <a16:creationId xmlns:a16="http://schemas.microsoft.com/office/drawing/2014/main" id="{B8C7776E-56FF-4FB7-AC48-7A38AAB545B7}"/>
+                <a16:creationId xmlns:a16="http://schemas.microsoft.com/office/drawing/2014/main" id="{47CD4CAC-A097-419C-92DD-F5F6E11C6523}"/>
               </a:ext>
             </a:extLst>
           </p:cNvPr>
@@ -1600,7 +1600,7 @@
           <p:cNvPr id="4" name="Content Placeholder 3">
             <a:extLst>
               <a:ext uri="{FF2B5EF4-FFF2-40B4-BE49-F238E27FC236}">
-                <a16:creationId xmlns:a16="http://schemas.microsoft.com/office/drawing/2014/main" id="{78A5F406-3400-4369-A039-6ED6025EA176}"/>
+                <a16:creationId xmlns:a16="http://schemas.microsoft.com/office/drawing/2014/main" id="{F3D438FE-EA86-45BE-BDCB-FD861DDCD93D}"/>
               </a:ext>
             </a:extLst>
           </p:cNvPr>
@@ -1662,7 +1662,7 @@
           <p:cNvPr id="5" name="Text Placeholder 4">
             <a:extLst>
               <a:ext uri="{FF2B5EF4-FFF2-40B4-BE49-F238E27FC236}">
-                <a16:creationId xmlns:a16="http://schemas.microsoft.com/office/drawing/2014/main" id="{762885CC-2122-4DC2-B886-B2BC0FB6C6A6}"/>
+                <a16:creationId xmlns:a16="http://schemas.microsoft.com/office/drawing/2014/main" id="{9E4FC599-FB47-48C4-B379-37F46A40C096}"/>
               </a:ext>
             </a:extLst>
           </p:cNvPr>
@@ -1733,7 +1733,7 @@
           <p:cNvPr id="6" name="Content Placeholder 5">
             <a:extLst>
               <a:ext uri="{FF2B5EF4-FFF2-40B4-BE49-F238E27FC236}">
-                <a16:creationId xmlns:a16="http://schemas.microsoft.com/office/drawing/2014/main" id="{76A3C938-C91D-4B1F-8E2D-8058925DA8E7}"/>
+                <a16:creationId xmlns:a16="http://schemas.microsoft.com/office/drawing/2014/main" id="{4FE0B1EA-8C95-4006-BA0C-D480F1F92F4B}"/>
               </a:ext>
             </a:extLst>
           </p:cNvPr>
@@ -1795,7 +1795,7 @@
           <p:cNvPr id="7" name="Date Placeholder 6">
             <a:extLst>
               <a:ext uri="{FF2B5EF4-FFF2-40B4-BE49-F238E27FC236}">
-                <a16:creationId xmlns:a16="http://schemas.microsoft.com/office/drawing/2014/main" id="{E66FFF6F-0BF2-4C32-B4F5-84E18658CA6D}"/>
+                <a16:creationId xmlns:a16="http://schemas.microsoft.com/office/drawing/2014/main" id="{AA7DA973-CF5B-4D1E-8276-C91B46680CE0}"/>
               </a:ext>
             </a:extLst>
           </p:cNvPr>
@@ -1811,9 +1811,9 @@
           <a:bodyPr/>
           <a:lstStyle/>
           <a:p>
-            <a:fld id="{68475CE9-0D53-4C49-BA8E-D50EFDE4F01D}" type="datetimeFigureOut">
+            <a:fld id="{0DDFDF14-270D-4278-A887-0FE7C53E2537}" type="datetimeFigureOut">
               <a:rPr lang="en-US" smtClean="0"/>
-              <a:t>10/24/2026</a:t>
+              <a:t>10/25/2026</a:t>
             </a:fld>
             <a:endParaRPr lang="en-US"/>
           </a:p>
@@ -1824,7 +1824,7 @@
           <p:cNvPr id="8" name="Footer Placeholder 7">
             <a:extLst>
               <a:ext uri="{FF2B5EF4-FFF2-40B4-BE49-F238E27FC236}">
-                <a16:creationId xmlns:a16="http://schemas.microsoft.com/office/drawing/2014/main" id="{791C0575-BEA8-47A1-A3C8-693A6461E12B}"/>
+                <a16:creationId xmlns:a16="http://schemas.microsoft.com/office/drawing/2014/main" id="{ECE1B746-0E0C-4548-BA93-5B07A9D5BC1E}"/>
               </a:ext>
             </a:extLst>
           </p:cNvPr>
@@ -1849,7 +1849,7 @@
           <p:cNvPr id="9" name="Slide Number Placeholder 8">
             <a:extLst>
               <a:ext uri="{FF2B5EF4-FFF2-40B4-BE49-F238E27FC236}">
-                <a16:creationId xmlns:a16="http://schemas.microsoft.com/office/drawing/2014/main" id="{7E956CCE-A145-4A4C-BE9C-04CE228BC924}"/>
+                <a16:creationId xmlns:a16="http://schemas.microsoft.com/office/drawing/2014/main" id="{DA88C9A6-C836-470E-9C2E-D4A012D6424C}"/>
               </a:ext>
             </a:extLst>
           </p:cNvPr>
@@ -1865,7 +1865,7 @@
           <a:bodyPr/>
           <a:lstStyle/>
           <a:p>
-            <a:fld id="{A6DADD06-3029-494A-BD87-B23A2BA0527F}" type="slidenum">
+            <a:fld id="{47A61D63-2B5F-48DC-98FA-4A3658F39B21}" type="slidenum">
               <a:rPr lang="en-US" smtClean="0"/>
               <a:t>‹#›</a:t>
             </a:fld>
@@ -1876,7 +1876,7 @@
     </p:spTree>
     <p:extLst>
       <p:ext uri="{BB962C8B-B14F-4D97-AF65-F5344CB8AC3E}">
-        <p14:creationId xmlns:p14="http://schemas.microsoft.com/office/powerpoint/2010/main" val="2713008018"/>
+        <p14:creationId xmlns:p14="http://schemas.microsoft.com/office/powerpoint/2010/main" val="3504106392"/>
       </p:ext>
     </p:extLst>
   </p:cSld>
@@ -1908,7 +1908,7 @@
           <p:cNvPr id="2" name="Title 1">
             <a:extLst>
               <a:ext uri="{FF2B5EF4-FFF2-40B4-BE49-F238E27FC236}">
-                <a16:creationId xmlns:a16="http://schemas.microsoft.com/office/drawing/2014/main" id="{22DC3083-C7B8-4EAA-BFF4-4BD71F7C40F6}"/>
+                <a16:creationId xmlns:a16="http://schemas.microsoft.com/office/drawing/2014/main" id="{42F2714F-5E42-48A2-9F6C-22CCA850E97F}"/>
               </a:ext>
             </a:extLst>
           </p:cNvPr>
@@ -1936,7 +1936,7 @@
           <p:cNvPr id="3" name="Date Placeholder 2">
             <a:extLst>
               <a:ext uri="{FF2B5EF4-FFF2-40B4-BE49-F238E27FC236}">
-                <a16:creationId xmlns:a16="http://schemas.microsoft.com/office/drawing/2014/main" id="{99847725-2E74-459E-ABAE-595B0B00286C}"/>
+                <a16:creationId xmlns:a16="http://schemas.microsoft.com/office/drawing/2014/main" id="{61288591-280D-4384-9D7B-AE65F91C4D44}"/>
               </a:ext>
             </a:extLst>
           </p:cNvPr>
@@ -1952,9 +1952,9 @@
           <a:bodyPr/>
           <a:lstStyle/>
           <a:p>
-            <a:fld id="{68475CE9-0D53-4C49-BA8E-D50EFDE4F01D}" type="datetimeFigureOut">
+            <a:fld id="{0DDFDF14-270D-4278-A887-0FE7C53E2537}" type="datetimeFigureOut">
               <a:rPr lang="en-US" smtClean="0"/>
-              <a:t>10/24/2026</a:t>
+              <a:t>10/25/2026</a:t>
             </a:fld>
             <a:endParaRPr lang="en-US"/>
           </a:p>
@@ -1965,7 +1965,7 @@
           <p:cNvPr id="4" name="Footer Placeholder 3">
             <a:extLst>
               <a:ext uri="{FF2B5EF4-FFF2-40B4-BE49-F238E27FC236}">
-                <a16:creationId xmlns:a16="http://schemas.microsoft.com/office/drawing/2014/main" id="{F280240D-6BD4-4510-9F24-851423D8FAC0}"/>
+                <a16:creationId xmlns:a16="http://schemas.microsoft.com/office/drawing/2014/main" id="{151BBBAE-8E48-402A-B3BE-0BEFA5BE1687}"/>
               </a:ext>
             </a:extLst>
           </p:cNvPr>
@@ -1990,7 +1990,7 @@
           <p:cNvPr id="5" name="Slide Number Placeholder 4">
             <a:extLst>
               <a:ext uri="{FF2B5EF4-FFF2-40B4-BE49-F238E27FC236}">
-                <a16:creationId xmlns:a16="http://schemas.microsoft.com/office/drawing/2014/main" id="{8987D603-8B76-4927-8147-8C29E968C335}"/>
+                <a16:creationId xmlns:a16="http://schemas.microsoft.com/office/drawing/2014/main" id="{6EA66FD1-E0DE-4656-9DDE-FAF1D281A054}"/>
               </a:ext>
             </a:extLst>
           </p:cNvPr>
@@ -2006,7 +2006,7 @@
           <a:bodyPr/>
           <a:lstStyle/>
           <a:p>
-            <a:fld id="{A6DADD06-3029-494A-BD87-B23A2BA0527F}" type="slidenum">
+            <a:fld id="{47A61D63-2B5F-48DC-98FA-4A3658F39B21}" type="slidenum">
               <a:rPr lang="en-US" smtClean="0"/>
               <a:t>‹#›</a:t>
             </a:fld>
@@ -2017,7 +2017,7 @@
     </p:spTree>
     <p:extLst>
       <p:ext uri="{BB962C8B-B14F-4D97-AF65-F5344CB8AC3E}">
-        <p14:creationId xmlns:p14="http://schemas.microsoft.com/office/powerpoint/2010/main" val="2778781017"/>
+        <p14:creationId xmlns:p14="http://schemas.microsoft.com/office/powerpoint/2010/main" val="1679529501"/>
       </p:ext>
     </p:extLst>
   </p:cSld>
@@ -2049,7 +2049,7 @@
           <p:cNvPr id="2" name="Date Placeholder 1">
             <a:extLst>
               <a:ext uri="{FF2B5EF4-FFF2-40B4-BE49-F238E27FC236}">
-                <a16:creationId xmlns:a16="http://schemas.microsoft.com/office/drawing/2014/main" id="{23E8157C-048A-4AD7-8FBF-D8984EF8BDCB}"/>
+                <a16:creationId xmlns:a16="http://schemas.microsoft.com/office/drawing/2014/main" id="{FCDE2895-D343-4E96-9BF6-01C7CC9650C3}"/>
               </a:ext>
             </a:extLst>
           </p:cNvPr>
@@ -2065,9 +2065,9 @@
           <a:bodyPr/>
           <a:lstStyle/>
           <a:p>
-            <a:fld id="{68475CE9-0D53-4C49-BA8E-D50EFDE4F01D}" type="datetimeFigureOut">
+            <a:fld id="{0DDFDF14-270D-4278-A887-0FE7C53E2537}" type="datetimeFigureOut">
               <a:rPr lang="en-US" smtClean="0"/>
-              <a:t>10/24/2026</a:t>
+              <a:t>10/25/2026</a:t>
             </a:fld>
             <a:endParaRPr lang="en-US"/>
           </a:p>
@@ -2078,7 +2078,7 @@
           <p:cNvPr id="3" name="Footer Placeholder 2">
             <a:extLst>
               <a:ext uri="{FF2B5EF4-FFF2-40B4-BE49-F238E27FC236}">
-                <a16:creationId xmlns:a16="http://schemas.microsoft.com/office/drawing/2014/main" id="{CA2E0BEB-1850-4DE0-A1AA-CCF2A0B6EE6E}"/>
+                <a16:creationId xmlns:a16="http://schemas.microsoft.com/office/drawing/2014/main" id="{9DA30B27-8B05-4D19-9304-4EDECE6CFCEE}"/>
               </a:ext>
             </a:extLst>
           </p:cNvPr>
@@ -2103,7 +2103,7 @@
           <p:cNvPr id="4" name="Slide Number Placeholder 3">
             <a:extLst>
               <a:ext uri="{FF2B5EF4-FFF2-40B4-BE49-F238E27FC236}">
-                <a16:creationId xmlns:a16="http://schemas.microsoft.com/office/drawing/2014/main" id="{B7119042-0F47-4759-AA55-884A7B172847}"/>
+                <a16:creationId xmlns:a16="http://schemas.microsoft.com/office/drawing/2014/main" id="{A669D065-7047-4BF1-B731-8EC3B14E9D02}"/>
               </a:ext>
             </a:extLst>
           </p:cNvPr>
@@ -2119,7 +2119,7 @@
           <a:bodyPr/>
           <a:lstStyle/>
           <a:p>
-            <a:fld id="{A6DADD06-3029-494A-BD87-B23A2BA0527F}" type="slidenum">
+            <a:fld id="{47A61D63-2B5F-48DC-98FA-4A3658F39B21}" type="slidenum">
               <a:rPr lang="en-US" smtClean="0"/>
               <a:t>‹#›</a:t>
             </a:fld>
@@ -2130,7 +2130,7 @@
     </p:spTree>
     <p:extLst>
       <p:ext uri="{BB962C8B-B14F-4D97-AF65-F5344CB8AC3E}">
-        <p14:creationId xmlns:p14="http://schemas.microsoft.com/office/powerpoint/2010/main" val="806006903"/>
+        <p14:creationId xmlns:p14="http://schemas.microsoft.com/office/powerpoint/2010/main" val="1197319075"/>
       </p:ext>
     </p:extLst>
   </p:cSld>
@@ -2162,7 +2162,7 @@
           <p:cNvPr id="2" name="Title 1">
             <a:extLst>
               <a:ext uri="{FF2B5EF4-FFF2-40B4-BE49-F238E27FC236}">
-                <a16:creationId xmlns:a16="http://schemas.microsoft.com/office/drawing/2014/main" id="{7EF3DA15-67D9-4CCA-9776-0395155CD134}"/>
+                <a16:creationId xmlns:a16="http://schemas.microsoft.com/office/drawing/2014/main" id="{4236ECD3-E07F-4071-8058-EBB814BABD8E}"/>
               </a:ext>
             </a:extLst>
           </p:cNvPr>
@@ -2199,7 +2199,7 @@
           <p:cNvPr id="3" name="Content Placeholder 2">
             <a:extLst>
               <a:ext uri="{FF2B5EF4-FFF2-40B4-BE49-F238E27FC236}">
-                <a16:creationId xmlns:a16="http://schemas.microsoft.com/office/drawing/2014/main" id="{74774A8A-91F3-41B6-A71E-5ED78555102D}"/>
+                <a16:creationId xmlns:a16="http://schemas.microsoft.com/office/drawing/2014/main" id="{080F9DCE-22BB-4416-AF48-84123361E57E}"/>
               </a:ext>
             </a:extLst>
           </p:cNvPr>
@@ -2289,7 +2289,7 @@
           <p:cNvPr id="4" name="Text Placeholder 3">
             <a:extLst>
               <a:ext uri="{FF2B5EF4-FFF2-40B4-BE49-F238E27FC236}">
-                <a16:creationId xmlns:a16="http://schemas.microsoft.com/office/drawing/2014/main" id="{DB82A013-6BA6-4524-8EB4-9DEAF32669D1}"/>
+                <a16:creationId xmlns:a16="http://schemas.microsoft.com/office/drawing/2014/main" id="{CCC69081-20D6-4E04-863D-AF25BE931312}"/>
               </a:ext>
             </a:extLst>
           </p:cNvPr>
@@ -2360,7 +2360,7 @@
           <p:cNvPr id="5" name="Date Placeholder 4">
             <a:extLst>
               <a:ext uri="{FF2B5EF4-FFF2-40B4-BE49-F238E27FC236}">
-                <a16:creationId xmlns:a16="http://schemas.microsoft.com/office/drawing/2014/main" id="{C86180BE-B183-4D3F-A159-F9329B09DE77}"/>
+                <a16:creationId xmlns:a16="http://schemas.microsoft.com/office/drawing/2014/main" id="{6A820CBA-90FB-464C-9A22-F6847F943103}"/>
               </a:ext>
             </a:extLst>
           </p:cNvPr>
@@ -2376,9 +2376,9 @@
           <a:bodyPr/>
           <a:lstStyle/>
           <a:p>
-            <a:fld id="{68475CE9-0D53-4C49-BA8E-D50EFDE4F01D}" type="datetimeFigureOut">
+            <a:fld id="{0DDFDF14-270D-4278-A887-0FE7C53E2537}" type="datetimeFigureOut">
               <a:rPr lang="en-US" smtClean="0"/>
-              <a:t>10/24/2026</a:t>
+              <a:t>10/25/2026</a:t>
             </a:fld>
             <a:endParaRPr lang="en-US"/>
           </a:p>
@@ -2389,7 +2389,7 @@
           <p:cNvPr id="6" name="Footer Placeholder 5">
             <a:extLst>
               <a:ext uri="{FF2B5EF4-FFF2-40B4-BE49-F238E27FC236}">
-                <a16:creationId xmlns:a16="http://schemas.microsoft.com/office/drawing/2014/main" id="{60303A89-8C2B-49C8-8BF4-EAC3FFB3A17C}"/>
+                <a16:creationId xmlns:a16="http://schemas.microsoft.com/office/drawing/2014/main" id="{EF50766A-1548-4751-9757-69DC13017870}"/>
               </a:ext>
             </a:extLst>
           </p:cNvPr>
@@ -2414,7 +2414,7 @@
           <p:cNvPr id="7" name="Slide Number Placeholder 6">
             <a:extLst>
               <a:ext uri="{FF2B5EF4-FFF2-40B4-BE49-F238E27FC236}">
-                <a16:creationId xmlns:a16="http://schemas.microsoft.com/office/drawing/2014/main" id="{2E1CBC18-266D-400E-8A51-EDE1FA7F062B}"/>
+                <a16:creationId xmlns:a16="http://schemas.microsoft.com/office/drawing/2014/main" id="{570BDA2F-4DDB-4875-9100-60A1587E8639}"/>
               </a:ext>
             </a:extLst>
           </p:cNvPr>
@@ -2430,7 +2430,7 @@
           <a:bodyPr/>
           <a:lstStyle/>
           <a:p>
-            <a:fld id="{A6DADD06-3029-494A-BD87-B23A2BA0527F}" type="slidenum">
+            <a:fld id="{47A61D63-2B5F-48DC-98FA-4A3658F39B21}" type="slidenum">
               <a:rPr lang="en-US" smtClean="0"/>
               <a:t>‹#›</a:t>
             </a:fld>
@@ -2441,7 +2441,7 @@
     </p:spTree>
     <p:extLst>
       <p:ext uri="{BB962C8B-B14F-4D97-AF65-F5344CB8AC3E}">
-        <p14:creationId xmlns:p14="http://schemas.microsoft.com/office/powerpoint/2010/main" val="232832942"/>
+        <p14:creationId xmlns:p14="http://schemas.microsoft.com/office/powerpoint/2010/main" val="2593349028"/>
       </p:ext>
     </p:extLst>
   </p:cSld>
@@ -2473,7 +2473,7 @@
           <p:cNvPr id="2" name="Title 1">
             <a:extLst>
               <a:ext uri="{FF2B5EF4-FFF2-40B4-BE49-F238E27FC236}">
-                <a16:creationId xmlns:a16="http://schemas.microsoft.com/office/drawing/2014/main" id="{AC48BA1F-61E4-4DE8-AFD1-8B62B9A2B392}"/>
+                <a16:creationId xmlns:a16="http://schemas.microsoft.com/office/drawing/2014/main" id="{D7C0D9E2-BE7E-4E46-828D-1D71B29070F0}"/>
               </a:ext>
             </a:extLst>
           </p:cNvPr>
@@ -2510,7 +2510,7 @@
           <p:cNvPr id="3" name="Picture Placeholder 2">
             <a:extLst>
               <a:ext uri="{FF2B5EF4-FFF2-40B4-BE49-F238E27FC236}">
-                <a16:creationId xmlns:a16="http://schemas.microsoft.com/office/drawing/2014/main" id="{52706352-8B26-4C3F-8FC1-D18D9DAD30BD}"/>
+                <a16:creationId xmlns:a16="http://schemas.microsoft.com/office/drawing/2014/main" id="{538DC2EF-4BB5-4167-B5E5-EE74550325CA}"/>
               </a:ext>
             </a:extLst>
           </p:cNvPr>
@@ -2577,7 +2577,7 @@
           <p:cNvPr id="4" name="Text Placeholder 3">
             <a:extLst>
               <a:ext uri="{FF2B5EF4-FFF2-40B4-BE49-F238E27FC236}">
-                <a16:creationId xmlns:a16="http://schemas.microsoft.com/office/drawing/2014/main" id="{2D73323A-E20F-4DA7-B3A3-283C845C2FBC}"/>
+                <a16:creationId xmlns:a16="http://schemas.microsoft.com/office/drawing/2014/main" id="{FB3951DC-76B5-427C-9EAD-83979F293EE6}"/>
               </a:ext>
             </a:extLst>
           </p:cNvPr>
@@ -2648,7 +2648,7 @@
           <p:cNvPr id="5" name="Date Placeholder 4">
             <a:extLst>
               <a:ext uri="{FF2B5EF4-FFF2-40B4-BE49-F238E27FC236}">
-                <a16:creationId xmlns:a16="http://schemas.microsoft.com/office/drawing/2014/main" id="{5BF0E4E7-2BCB-4969-987A-C293930E4083}"/>
+                <a16:creationId xmlns:a16="http://schemas.microsoft.com/office/drawing/2014/main" id="{60825D97-2250-46F2-B9B7-163A6080E4EF}"/>
               </a:ext>
             </a:extLst>
           </p:cNvPr>
@@ -2664,9 +2664,9 @@
           <a:bodyPr/>
           <a:lstStyle/>
           <a:p>
-            <a:fld id="{68475CE9-0D53-4C49-BA8E-D50EFDE4F01D}" type="datetimeFigureOut">
+            <a:fld id="{0DDFDF14-270D-4278-A887-0FE7C53E2537}" type="datetimeFigureOut">
               <a:rPr lang="en-US" smtClean="0"/>
-              <a:t>10/24/2026</a:t>
+              <a:t>10/25/2026</a:t>
             </a:fld>
             <a:endParaRPr lang="en-US"/>
           </a:p>
@@ -2677,7 +2677,7 @@
           <p:cNvPr id="6" name="Footer Placeholder 5">
             <a:extLst>
               <a:ext uri="{FF2B5EF4-FFF2-40B4-BE49-F238E27FC236}">
-                <a16:creationId xmlns:a16="http://schemas.microsoft.com/office/drawing/2014/main" id="{84E846A4-ACDC-43A2-B16A-B3AB24ACC99D}"/>
+                <a16:creationId xmlns:a16="http://schemas.microsoft.com/office/drawing/2014/main" id="{ACAE9D74-E8DC-4DCD-BAE5-8273F2C920E7}"/>
               </a:ext>
             </a:extLst>
           </p:cNvPr>
@@ -2702,7 +2702,7 @@
           <p:cNvPr id="7" name="Slide Number Placeholder 6">
             <a:extLst>
               <a:ext uri="{FF2B5EF4-FFF2-40B4-BE49-F238E27FC236}">
-                <a16:creationId xmlns:a16="http://schemas.microsoft.com/office/drawing/2014/main" id="{57821BC5-7888-47AC-A459-7E2E91EA9DE0}"/>
+                <a16:creationId xmlns:a16="http://schemas.microsoft.com/office/drawing/2014/main" id="{D8D6B0DD-7DE8-4EF7-AD34-36AC75103E15}"/>
               </a:ext>
             </a:extLst>
           </p:cNvPr>
@@ -2718,7 +2718,7 @@
           <a:bodyPr/>
           <a:lstStyle/>
           <a:p>
-            <a:fld id="{A6DADD06-3029-494A-BD87-B23A2BA0527F}" type="slidenum">
+            <a:fld id="{47A61D63-2B5F-48DC-98FA-4A3658F39B21}" type="slidenum">
               <a:rPr lang="en-US" smtClean="0"/>
               <a:t>‹#›</a:t>
             </a:fld>
@@ -2729,7 +2729,7 @@
     </p:spTree>
     <p:extLst>
       <p:ext uri="{BB962C8B-B14F-4D97-AF65-F5344CB8AC3E}">
-        <p14:creationId xmlns:p14="http://schemas.microsoft.com/office/powerpoint/2010/main" val="3742329587"/>
+        <p14:creationId xmlns:p14="http://schemas.microsoft.com/office/powerpoint/2010/main" val="2846334428"/>
       </p:ext>
     </p:extLst>
   </p:cSld>
@@ -2766,7 +2766,7 @@
           <p:cNvPr id="2" name="Title Placeholder 1">
             <a:extLst>
               <a:ext uri="{FF2B5EF4-FFF2-40B4-BE49-F238E27FC236}">
-                <a16:creationId xmlns:a16="http://schemas.microsoft.com/office/drawing/2014/main" id="{108FF136-1418-4D01-ADB2-F89DF3FE0378}"/>
+                <a16:creationId xmlns:a16="http://schemas.microsoft.com/office/drawing/2014/main" id="{96E5A5AC-3180-49F8-9F31-CDD540098FB2}"/>
               </a:ext>
             </a:extLst>
           </p:cNvPr>
@@ -2804,7 +2804,7 @@
           <p:cNvPr id="3" name="Text Placeholder 2">
             <a:extLst>
               <a:ext uri="{FF2B5EF4-FFF2-40B4-BE49-F238E27FC236}">
-                <a16:creationId xmlns:a16="http://schemas.microsoft.com/office/drawing/2014/main" id="{CF1EDC11-DEAB-4254-9ADD-A81B4087C702}"/>
+                <a16:creationId xmlns:a16="http://schemas.microsoft.com/office/drawing/2014/main" id="{5FF63E3D-B4D5-48BE-9E7D-0888ABE39A7B}"/>
               </a:ext>
             </a:extLst>
           </p:cNvPr>
@@ -2871,7 +2871,7 @@
           <p:cNvPr id="4" name="Date Placeholder 3">
             <a:extLst>
               <a:ext uri="{FF2B5EF4-FFF2-40B4-BE49-F238E27FC236}">
-                <a16:creationId xmlns:a16="http://schemas.microsoft.com/office/drawing/2014/main" id="{44F80AAF-95DA-475D-947B-28CDB01D3650}"/>
+                <a16:creationId xmlns:a16="http://schemas.microsoft.com/office/drawing/2014/main" id="{A64A8F65-4B3E-4654-B673-7066527ACB1F}"/>
               </a:ext>
             </a:extLst>
           </p:cNvPr>
@@ -2905,9 +2905,9 @@
             </a:lvl1pPr>
           </a:lstStyle>
           <a:p>
-            <a:fld id="{68475CE9-0D53-4C49-BA8E-D50EFDE4F01D}" type="datetimeFigureOut">
+            <a:fld id="{0DDFDF14-270D-4278-A887-0FE7C53E2537}" type="datetimeFigureOut">
               <a:rPr lang="en-US" smtClean="0"/>
-              <a:t>10/24/2026</a:t>
+              <a:t>10/25/2026</a:t>
             </a:fld>
             <a:endParaRPr lang="en-US"/>
           </a:p>
@@ -2918,7 +2918,7 @@
           <p:cNvPr id="5" name="Footer Placeholder 4">
             <a:extLst>
               <a:ext uri="{FF2B5EF4-FFF2-40B4-BE49-F238E27FC236}">
-                <a16:creationId xmlns:a16="http://schemas.microsoft.com/office/drawing/2014/main" id="{4A9E7236-6148-42E8-BBBE-4EA23489A910}"/>
+                <a16:creationId xmlns:a16="http://schemas.microsoft.com/office/drawing/2014/main" id="{DE02CA70-6E01-46A7-B420-176F906AD6BC}"/>
               </a:ext>
             </a:extLst>
           </p:cNvPr>
@@ -2961,7 +2961,7 @@
           <p:cNvPr id="6" name="Slide Number Placeholder 5">
             <a:extLst>
               <a:ext uri="{FF2B5EF4-FFF2-40B4-BE49-F238E27FC236}">
-                <a16:creationId xmlns:a16="http://schemas.microsoft.com/office/drawing/2014/main" id="{9A2E98C8-6667-42D6-B2E7-1A45BC009159}"/>
+                <a16:creationId xmlns:a16="http://schemas.microsoft.com/office/drawing/2014/main" id="{81DD2CDA-48A2-4D8E-90EC-94A0FC61E05A}"/>
               </a:ext>
             </a:extLst>
           </p:cNvPr>
@@ -2995,7 +2995,7 @@
             </a:lvl1pPr>
           </a:lstStyle>
           <a:p>
-            <a:fld id="{A6DADD06-3029-494A-BD87-B23A2BA0527F}" type="slidenum">
+            <a:fld id="{47A61D63-2B5F-48DC-98FA-4A3658F39B21}" type="slidenum">
               <a:rPr lang="en-US" smtClean="0"/>
               <a:t>‹#›</a:t>
             </a:fld>
@@ -3006,7 +3006,7 @@
     </p:spTree>
     <p:extLst>
       <p:ext uri="{BB962C8B-B14F-4D97-AF65-F5344CB8AC3E}">
-        <p14:creationId xmlns:p14="http://schemas.microsoft.com/office/powerpoint/2010/main" val="1909773171"/>
+        <p14:creationId xmlns:p14="http://schemas.microsoft.com/office/powerpoint/2010/main" val="780440700"/>
       </p:ext>
     </p:extLst>
   </p:cSld>
@@ -3337,7 +3337,7 @@
           <p:cNvPr id="2" name="Rectangle 1">
             <a:extLst>
               <a:ext uri="{FF2B5EF4-FFF2-40B4-BE49-F238E27FC236}">
-                <a16:creationId xmlns:a16="http://schemas.microsoft.com/office/drawing/2014/main" id="{AD710E86-E695-4A4B-A795-8A16245FA52D}"/>
+                <a16:creationId xmlns:a16="http://schemas.microsoft.com/office/drawing/2014/main" id="{E11B979A-0540-40D2-A365-E0860B0043BD}"/>
               </a:ext>
             </a:extLst>
           </p:cNvPr>
@@ -3405,7 +3405,7 @@
           <p:cNvPr id="3" name="TextBox 2">
             <a:extLst>
               <a:ext uri="{FF2B5EF4-FFF2-40B4-BE49-F238E27FC236}">
-                <a16:creationId xmlns:a16="http://schemas.microsoft.com/office/drawing/2014/main" id="{2C96332A-8F85-4896-94B4-38F643D9316E}"/>
+                <a16:creationId xmlns:a16="http://schemas.microsoft.com/office/drawing/2014/main" id="{0951E0A5-465D-4B99-8591-444975296F32}"/>
               </a:ext>
             </a:extLst>
           </p:cNvPr>
@@ -3445,7 +3445,7 @@
           <p:cNvPr id="4" name="TextBox 3">
             <a:extLst>
               <a:ext uri="{FF2B5EF4-FFF2-40B4-BE49-F238E27FC236}">
-                <a16:creationId xmlns:a16="http://schemas.microsoft.com/office/drawing/2014/main" id="{D106AF6D-F597-4E41-9963-A57B0F7B3703}"/>
+                <a16:creationId xmlns:a16="http://schemas.microsoft.com/office/drawing/2014/main" id="{783CF311-3368-43D3-BB0F-C72E9D123ACF}"/>
               </a:ext>
             </a:extLst>
           </p:cNvPr>
@@ -3485,7 +3485,7 @@
           <p:cNvPr id="5" name="TextBox 4">
             <a:extLst>
               <a:ext uri="{FF2B5EF4-FFF2-40B4-BE49-F238E27FC236}">
-                <a16:creationId xmlns:a16="http://schemas.microsoft.com/office/drawing/2014/main" id="{15ABF98D-16CF-44B9-BC98-9134195606EF}"/>
+                <a16:creationId xmlns:a16="http://schemas.microsoft.com/office/drawing/2014/main" id="{D85933F8-564D-40A8-A325-E69683558C79}"/>
               </a:ext>
             </a:extLst>
           </p:cNvPr>
@@ -3525,7 +3525,7 @@
           <p:cNvPr id="6" name="TextBox 5">
             <a:extLst>
               <a:ext uri="{FF2B5EF4-FFF2-40B4-BE49-F238E27FC236}">
-                <a16:creationId xmlns:a16="http://schemas.microsoft.com/office/drawing/2014/main" id="{BDF711BD-948E-4B49-803A-E158403323C9}"/>
+                <a16:creationId xmlns:a16="http://schemas.microsoft.com/office/drawing/2014/main" id="{52EEEC9C-F6AE-4258-ABF5-7792CC0AAC77}"/>
               </a:ext>
             </a:extLst>
           </p:cNvPr>
@@ -3565,7 +3565,7 @@
           <p:cNvPr id="7" name="Rectangle 6">
             <a:extLst>
               <a:ext uri="{FF2B5EF4-FFF2-40B4-BE49-F238E27FC236}">
-                <a16:creationId xmlns:a16="http://schemas.microsoft.com/office/drawing/2014/main" id="{5C9096C2-9C8E-4C47-8C46-4ECD0529EE55}"/>
+                <a16:creationId xmlns:a16="http://schemas.microsoft.com/office/drawing/2014/main" id="{B16469CF-13AB-481A-BEC2-0E3B34D0D575}"/>
               </a:ext>
             </a:extLst>
           </p:cNvPr>
@@ -3633,7 +3633,7 @@
           <p:cNvPr id="8" name="TextBox 7">
             <a:extLst>
               <a:ext uri="{FF2B5EF4-FFF2-40B4-BE49-F238E27FC236}">
-                <a16:creationId xmlns:a16="http://schemas.microsoft.com/office/drawing/2014/main" id="{451D1548-EBD7-4176-B78A-292F4BD5270B}"/>
+                <a16:creationId xmlns:a16="http://schemas.microsoft.com/office/drawing/2014/main" id="{8936511C-61A7-434A-BC17-3CF63AEEE3F4}"/>
               </a:ext>
             </a:extLst>
           </p:cNvPr>
@@ -3671,7 +3671,7 @@
     </p:spTree>
     <p:extLst>
       <p:ext uri="{BB962C8B-B14F-4D97-AF65-F5344CB8AC3E}">
-        <p14:creationId xmlns:p14="http://schemas.microsoft.com/office/powerpoint/2010/main" val="1122083090"/>
+        <p14:creationId xmlns:p14="http://schemas.microsoft.com/office/powerpoint/2010/main" val="17308525"/>
       </p:ext>
     </p:extLst>
   </p:cSld>
@@ -3711,7 +3711,7 @@
           <p:cNvPr id="2" name="Rectangle 1">
             <a:extLst>
               <a:ext uri="{FF2B5EF4-FFF2-40B4-BE49-F238E27FC236}">
-                <a16:creationId xmlns:a16="http://schemas.microsoft.com/office/drawing/2014/main" id="{919A858E-93ED-45D2-83FF-F0988B1B88DE}"/>
+                <a16:creationId xmlns:a16="http://schemas.microsoft.com/office/drawing/2014/main" id="{97E12F80-18F5-47C1-8097-B06DBF61C8D8}"/>
               </a:ext>
             </a:extLst>
           </p:cNvPr>
@@ -3779,7 +3779,7 @@
           <p:cNvPr id="3" name="TextBox 2">
             <a:extLst>
               <a:ext uri="{FF2B5EF4-FFF2-40B4-BE49-F238E27FC236}">
-                <a16:creationId xmlns:a16="http://schemas.microsoft.com/office/drawing/2014/main" id="{994DB5C4-5A54-43A9-B61A-A67289532207}"/>
+                <a16:creationId xmlns:a16="http://schemas.microsoft.com/office/drawing/2014/main" id="{4FA3D8AD-2255-495C-952D-9782B3F4F8D9}"/>
               </a:ext>
             </a:extLst>
           </p:cNvPr>
@@ -3819,7 +3819,7 @@
           <p:cNvPr id="5" name="Graphic 4">
             <a:extLst>
               <a:ext uri="{FF2B5EF4-FFF2-40B4-BE49-F238E27FC236}">
-                <a16:creationId xmlns:a16="http://schemas.microsoft.com/office/drawing/2014/main" id="{2D134595-5C32-4525-A059-DCEDDFC352FB}"/>
+                <a16:creationId xmlns:a16="http://schemas.microsoft.com/office/drawing/2014/main" id="{40A0A6DD-4AA4-4285-909C-134A3BC737CF}"/>
               </a:ext>
             </a:extLst>
           </p:cNvPr>
@@ -3858,7 +3858,7 @@
           <p:cNvPr id="6" name="Rectangle 5">
             <a:extLst>
               <a:ext uri="{FF2B5EF4-FFF2-40B4-BE49-F238E27FC236}">
-                <a16:creationId xmlns:a16="http://schemas.microsoft.com/office/drawing/2014/main" id="{7D9CECDC-CC5D-471E-954A-A2171363D4E8}"/>
+                <a16:creationId xmlns:a16="http://schemas.microsoft.com/office/drawing/2014/main" id="{8B2C4BC9-1427-4181-BB01-42F7C74E0204}"/>
               </a:ext>
             </a:extLst>
           </p:cNvPr>
@@ -3926,7 +3926,7 @@
           <p:cNvPr id="7" name="TextBox 6">
             <a:extLst>
               <a:ext uri="{FF2B5EF4-FFF2-40B4-BE49-F238E27FC236}">
-                <a16:creationId xmlns:a16="http://schemas.microsoft.com/office/drawing/2014/main" id="{9370A616-0D16-4BE7-A9D9-F04B5F37065B}"/>
+                <a16:creationId xmlns:a16="http://schemas.microsoft.com/office/drawing/2014/main" id="{52138015-1526-4CBC-B3C3-79A0A496090B}"/>
               </a:ext>
             </a:extLst>
           </p:cNvPr>
@@ -3966,7 +3966,7 @@
           <p:cNvPr id="8" name="TextBox 7">
             <a:extLst>
               <a:ext uri="{FF2B5EF4-FFF2-40B4-BE49-F238E27FC236}">
-                <a16:creationId xmlns:a16="http://schemas.microsoft.com/office/drawing/2014/main" id="{BC17FA80-8D1F-40DD-9FB6-4BF8019B5C84}"/>
+                <a16:creationId xmlns:a16="http://schemas.microsoft.com/office/drawing/2014/main" id="{F7604B0E-4735-4DD9-A38E-B4268EDF5EFE}"/>
               </a:ext>
             </a:extLst>
           </p:cNvPr>
@@ -4006,7 +4006,7 @@
           <p:cNvPr id="9" name="TextBox 8">
             <a:extLst>
               <a:ext uri="{FF2B5EF4-FFF2-40B4-BE49-F238E27FC236}">
-                <a16:creationId xmlns:a16="http://schemas.microsoft.com/office/drawing/2014/main" id="{EE0F6F02-F768-4F4A-ADD6-2F851EC02E83}"/>
+                <a16:creationId xmlns:a16="http://schemas.microsoft.com/office/drawing/2014/main" id="{D93F4943-040A-4F3A-B204-111CB03AF75A}"/>
               </a:ext>
             </a:extLst>
           </p:cNvPr>
@@ -4046,7 +4046,7 @@
           <p:cNvPr id="10" name="TextBox 9">
             <a:extLst>
               <a:ext uri="{FF2B5EF4-FFF2-40B4-BE49-F238E27FC236}">
-                <a16:creationId xmlns:a16="http://schemas.microsoft.com/office/drawing/2014/main" id="{E0BDBA7D-3136-4B63-9A56-B32E15EB3E89}"/>
+                <a16:creationId xmlns:a16="http://schemas.microsoft.com/office/drawing/2014/main" id="{DD4E8F52-E607-4155-A08C-A15514DD739D}"/>
               </a:ext>
             </a:extLst>
           </p:cNvPr>
@@ -4086,7 +4086,7 @@
           <p:cNvPr id="11" name="TextBox 10">
             <a:extLst>
               <a:ext uri="{FF2B5EF4-FFF2-40B4-BE49-F238E27FC236}">
-                <a16:creationId xmlns:a16="http://schemas.microsoft.com/office/drawing/2014/main" id="{65F972BB-A8E4-4FA3-B733-A360A5FAA2DE}"/>
+                <a16:creationId xmlns:a16="http://schemas.microsoft.com/office/drawing/2014/main" id="{929EF954-90DD-4E40-8625-D20E4A489538}"/>
               </a:ext>
             </a:extLst>
           </p:cNvPr>
@@ -4126,7 +4126,7 @@
           <p:cNvPr id="12" name="TextBox 11">
             <a:extLst>
               <a:ext uri="{FF2B5EF4-FFF2-40B4-BE49-F238E27FC236}">
-                <a16:creationId xmlns:a16="http://schemas.microsoft.com/office/drawing/2014/main" id="{C824F511-E87D-42A1-BF46-386CE719B265}"/>
+                <a16:creationId xmlns:a16="http://schemas.microsoft.com/office/drawing/2014/main" id="{38AD1974-986F-4982-983B-A16F408967A3}"/>
               </a:ext>
             </a:extLst>
           </p:cNvPr>
@@ -4166,7 +4166,7 @@
           <p:cNvPr id="13" name="TextBox 12">
             <a:extLst>
               <a:ext uri="{FF2B5EF4-FFF2-40B4-BE49-F238E27FC236}">
-                <a16:creationId xmlns:a16="http://schemas.microsoft.com/office/drawing/2014/main" id="{2D3E042B-4088-45A7-93EC-03A671A31043}"/>
+                <a16:creationId xmlns:a16="http://schemas.microsoft.com/office/drawing/2014/main" id="{B3406912-C499-404D-903F-A96774698459}"/>
               </a:ext>
             </a:extLst>
           </p:cNvPr>
@@ -4206,7 +4206,7 @@
           <p:cNvPr id="14" name="TextBox 13">
             <a:extLst>
               <a:ext uri="{FF2B5EF4-FFF2-40B4-BE49-F238E27FC236}">
-                <a16:creationId xmlns:a16="http://schemas.microsoft.com/office/drawing/2014/main" id="{C9F5AE33-2A8A-41AF-81F2-8206FA273764}"/>
+                <a16:creationId xmlns:a16="http://schemas.microsoft.com/office/drawing/2014/main" id="{EAF93F49-8D89-492C-9DCB-BA879CE44914}"/>
               </a:ext>
             </a:extLst>
           </p:cNvPr>
@@ -4246,7 +4246,7 @@
           <p:cNvPr id="15" name="TextBox 14">
             <a:extLst>
               <a:ext uri="{FF2B5EF4-FFF2-40B4-BE49-F238E27FC236}">
-                <a16:creationId xmlns:a16="http://schemas.microsoft.com/office/drawing/2014/main" id="{42795FF5-725B-4F26-B83C-1F67EDD10EAD}"/>
+                <a16:creationId xmlns:a16="http://schemas.microsoft.com/office/drawing/2014/main" id="{AB6244F4-F738-41BB-A9D6-AD02C01B0B17}"/>
               </a:ext>
             </a:extLst>
           </p:cNvPr>
@@ -4286,7 +4286,7 @@
           <p:cNvPr id="16" name="TextBox 15">
             <a:extLst>
               <a:ext uri="{FF2B5EF4-FFF2-40B4-BE49-F238E27FC236}">
-                <a16:creationId xmlns:a16="http://schemas.microsoft.com/office/drawing/2014/main" id="{AB7D5BD2-03AF-44C3-8F9A-36A7BA6443FE}"/>
+                <a16:creationId xmlns:a16="http://schemas.microsoft.com/office/drawing/2014/main" id="{BE7634C2-6CB4-45FF-B8CB-B7CB835ECA66}"/>
               </a:ext>
             </a:extLst>
           </p:cNvPr>
@@ -4324,7 +4324,7 @@
     </p:spTree>
     <p:extLst>
       <p:ext uri="{BB962C8B-B14F-4D97-AF65-F5344CB8AC3E}">
-        <p14:creationId xmlns:p14="http://schemas.microsoft.com/office/powerpoint/2010/main" val="2406155675"/>
+        <p14:creationId xmlns:p14="http://schemas.microsoft.com/office/powerpoint/2010/main" val="2254073397"/>
       </p:ext>
     </p:extLst>
   </p:cSld>
@@ -4364,7 +4364,7 @@
           <p:cNvPr id="2" name="Rectangle 1">
             <a:extLst>
               <a:ext uri="{FF2B5EF4-FFF2-40B4-BE49-F238E27FC236}">
-                <a16:creationId xmlns:a16="http://schemas.microsoft.com/office/drawing/2014/main" id="{340E1CD1-B4AF-4CE5-B846-18F3ACDEAEB5}"/>
+                <a16:creationId xmlns:a16="http://schemas.microsoft.com/office/drawing/2014/main" id="{3DCB8DF7-46B1-4AC5-A75D-78C3F3D2BDC1}"/>
               </a:ext>
             </a:extLst>
           </p:cNvPr>
@@ -4432,7 +4432,7 @@
           <p:cNvPr id="3" name="TextBox 2">
             <a:extLst>
               <a:ext uri="{FF2B5EF4-FFF2-40B4-BE49-F238E27FC236}">
-                <a16:creationId xmlns:a16="http://schemas.microsoft.com/office/drawing/2014/main" id="{B58A1CD3-F8A8-458F-A4BC-F063D4A69550}"/>
+                <a16:creationId xmlns:a16="http://schemas.microsoft.com/office/drawing/2014/main" id="{E2EAF6B1-3E13-41D2-B51A-64BE1395C575}"/>
               </a:ext>
             </a:extLst>
           </p:cNvPr>
@@ -4472,7 +4472,7 @@
           <p:cNvPr id="4" name="TextBox 3">
             <a:extLst>
               <a:ext uri="{FF2B5EF4-FFF2-40B4-BE49-F238E27FC236}">
-                <a16:creationId xmlns:a16="http://schemas.microsoft.com/office/drawing/2014/main" id="{6830FAB0-1194-4E91-9617-438FF3585A96}"/>
+                <a16:creationId xmlns:a16="http://schemas.microsoft.com/office/drawing/2014/main" id="{79ECE8B6-AE79-4823-A283-A9D6AF3398A2}"/>
               </a:ext>
             </a:extLst>
           </p:cNvPr>
@@ -4512,7 +4512,7 @@
           <p:cNvPr id="5" name="TextBox 4">
             <a:extLst>
               <a:ext uri="{FF2B5EF4-FFF2-40B4-BE49-F238E27FC236}">
-                <a16:creationId xmlns:a16="http://schemas.microsoft.com/office/drawing/2014/main" id="{BC1D6215-34F4-4827-B15D-194080A33B09}"/>
+                <a16:creationId xmlns:a16="http://schemas.microsoft.com/office/drawing/2014/main" id="{CD0FE008-6C36-4986-8F96-7CC90605D51D}"/>
               </a:ext>
             </a:extLst>
           </p:cNvPr>
@@ -4552,7 +4552,7 @@
           <p:cNvPr id="7" name="Graphic 6">
             <a:extLst>
               <a:ext uri="{FF2B5EF4-FFF2-40B4-BE49-F238E27FC236}">
-                <a16:creationId xmlns:a16="http://schemas.microsoft.com/office/drawing/2014/main" id="{363417E6-CE3D-419B-ABCA-501172D612AB}"/>
+                <a16:creationId xmlns:a16="http://schemas.microsoft.com/office/drawing/2014/main" id="{0093B30E-055F-4C6C-85E1-7FB8670BF965}"/>
               </a:ext>
             </a:extLst>
           </p:cNvPr>
@@ -4591,7 +4591,7 @@
           <p:cNvPr id="8" name="TextBox 7">
             <a:extLst>
               <a:ext uri="{FF2B5EF4-FFF2-40B4-BE49-F238E27FC236}">
-                <a16:creationId xmlns:a16="http://schemas.microsoft.com/office/drawing/2014/main" id="{3899A197-508F-4FC0-9485-A005EAEB6EC9}"/>
+                <a16:creationId xmlns:a16="http://schemas.microsoft.com/office/drawing/2014/main" id="{15B0275F-2547-487F-9D1A-0D1B49F07BE5}"/>
               </a:ext>
             </a:extLst>
           </p:cNvPr>
@@ -4631,7 +4631,7 @@
           <p:cNvPr id="9" name="TextBox 8">
             <a:extLst>
               <a:ext uri="{FF2B5EF4-FFF2-40B4-BE49-F238E27FC236}">
-                <a16:creationId xmlns:a16="http://schemas.microsoft.com/office/drawing/2014/main" id="{ABA67133-0331-4F4A-B461-A7A879344219}"/>
+                <a16:creationId xmlns:a16="http://schemas.microsoft.com/office/drawing/2014/main" id="{B204BE75-A47D-44E4-B3CE-310E461695B0}"/>
               </a:ext>
             </a:extLst>
           </p:cNvPr>
@@ -4671,7 +4671,7 @@
           <p:cNvPr id="11" name="Graphic 10">
             <a:extLst>
               <a:ext uri="{FF2B5EF4-FFF2-40B4-BE49-F238E27FC236}">
-                <a16:creationId xmlns:a16="http://schemas.microsoft.com/office/drawing/2014/main" id="{D9D5698C-37D8-4DB5-A5AE-F8614352C261}"/>
+                <a16:creationId xmlns:a16="http://schemas.microsoft.com/office/drawing/2014/main" id="{B07AAAB4-BE9C-4CAE-A9D7-F139531B6015}"/>
               </a:ext>
             </a:extLst>
           </p:cNvPr>
@@ -4710,7 +4710,7 @@
           <p:cNvPr id="12" name="TextBox 11">
             <a:extLst>
               <a:ext uri="{FF2B5EF4-FFF2-40B4-BE49-F238E27FC236}">
-                <a16:creationId xmlns:a16="http://schemas.microsoft.com/office/drawing/2014/main" id="{22A16782-63DF-4CCE-BD85-18969C786911}"/>
+                <a16:creationId xmlns:a16="http://schemas.microsoft.com/office/drawing/2014/main" id="{C1B74CB1-E02A-4D93-93DB-67FE2FD958E2}"/>
               </a:ext>
             </a:extLst>
           </p:cNvPr>
@@ -4748,7 +4748,7 @@
     </p:spTree>
     <p:extLst>
       <p:ext uri="{BB962C8B-B14F-4D97-AF65-F5344CB8AC3E}">
-        <p14:creationId xmlns:p14="http://schemas.microsoft.com/office/powerpoint/2010/main" val="3157411046"/>
+        <p14:creationId xmlns:p14="http://schemas.microsoft.com/office/powerpoint/2010/main" val="4271687158"/>
       </p:ext>
     </p:extLst>
   </p:cSld>
@@ -4788,7 +4788,7 @@
           <p:cNvPr id="2" name="Rectangle 1">
             <a:extLst>
               <a:ext uri="{FF2B5EF4-FFF2-40B4-BE49-F238E27FC236}">
-                <a16:creationId xmlns:a16="http://schemas.microsoft.com/office/drawing/2014/main" id="{41FFCFDC-E8C7-4B72-8654-ACE932D18319}"/>
+                <a16:creationId xmlns:a16="http://schemas.microsoft.com/office/drawing/2014/main" id="{1046048E-AA90-4FC9-A1CD-9D19CFD14F67}"/>
               </a:ext>
             </a:extLst>
           </p:cNvPr>
@@ -4856,7 +4856,7 @@
           <p:cNvPr id="3" name="TextBox 2">
             <a:extLst>
               <a:ext uri="{FF2B5EF4-FFF2-40B4-BE49-F238E27FC236}">
-                <a16:creationId xmlns:a16="http://schemas.microsoft.com/office/drawing/2014/main" id="{CDFD9B74-C662-47E0-BD02-9757A405A7F6}"/>
+                <a16:creationId xmlns:a16="http://schemas.microsoft.com/office/drawing/2014/main" id="{893A5B26-AFAE-41D7-9AB4-F58EF66B56A7}"/>
               </a:ext>
             </a:extLst>
           </p:cNvPr>
@@ -4896,7 +4896,7 @@
           <p:cNvPr id="5" name="Graphic 4">
             <a:extLst>
               <a:ext uri="{FF2B5EF4-FFF2-40B4-BE49-F238E27FC236}">
-                <a16:creationId xmlns:a16="http://schemas.microsoft.com/office/drawing/2014/main" id="{6A64F2F8-5780-488D-9F0F-527B61BCB38F}"/>
+                <a16:creationId xmlns:a16="http://schemas.microsoft.com/office/drawing/2014/main" id="{2D84C9F2-B05F-4BAA-90D5-F584452D58C3}"/>
               </a:ext>
             </a:extLst>
           </p:cNvPr>
@@ -4935,7 +4935,7 @@
           <p:cNvPr id="6" name="Rectangle 5">
             <a:extLst>
               <a:ext uri="{FF2B5EF4-FFF2-40B4-BE49-F238E27FC236}">
-                <a16:creationId xmlns:a16="http://schemas.microsoft.com/office/drawing/2014/main" id="{26F0C39E-4418-40A1-B571-80C6341C9CF2}"/>
+                <a16:creationId xmlns:a16="http://schemas.microsoft.com/office/drawing/2014/main" id="{B5ABE4C1-5F34-4B12-9828-3D0F060E3A30}"/>
               </a:ext>
             </a:extLst>
           </p:cNvPr>
@@ -5003,7 +5003,7 @@
           <p:cNvPr id="7" name="TextBox 6">
             <a:extLst>
               <a:ext uri="{FF2B5EF4-FFF2-40B4-BE49-F238E27FC236}">
-                <a16:creationId xmlns:a16="http://schemas.microsoft.com/office/drawing/2014/main" id="{5333CDA4-587F-4E0E-BBCF-1E3999796CDF}"/>
+                <a16:creationId xmlns:a16="http://schemas.microsoft.com/office/drawing/2014/main" id="{2928F1FA-E473-4BB5-9E21-DD8C89F5598D}"/>
               </a:ext>
             </a:extLst>
           </p:cNvPr>
@@ -5043,7 +5043,7 @@
           <p:cNvPr id="8" name="TextBox 7">
             <a:extLst>
               <a:ext uri="{FF2B5EF4-FFF2-40B4-BE49-F238E27FC236}">
-                <a16:creationId xmlns:a16="http://schemas.microsoft.com/office/drawing/2014/main" id="{FB53054F-84E4-4883-B9DA-EC53A418A3BD}"/>
+                <a16:creationId xmlns:a16="http://schemas.microsoft.com/office/drawing/2014/main" id="{1B8B92B8-A3A6-4329-8629-8C42C281D1C3}"/>
               </a:ext>
             </a:extLst>
           </p:cNvPr>
@@ -5083,7 +5083,7 @@
           <p:cNvPr id="9" name="TextBox 8">
             <a:extLst>
               <a:ext uri="{FF2B5EF4-FFF2-40B4-BE49-F238E27FC236}">
-                <a16:creationId xmlns:a16="http://schemas.microsoft.com/office/drawing/2014/main" id="{12AF123B-20EC-487D-9AE9-7790EC6A41DA}"/>
+                <a16:creationId xmlns:a16="http://schemas.microsoft.com/office/drawing/2014/main" id="{FF943CBB-EA4A-4D7A-B0B9-E4EF0283B62B}"/>
               </a:ext>
             </a:extLst>
           </p:cNvPr>
@@ -5123,7 +5123,7 @@
           <p:cNvPr id="10" name="TextBox 9">
             <a:extLst>
               <a:ext uri="{FF2B5EF4-FFF2-40B4-BE49-F238E27FC236}">
-                <a16:creationId xmlns:a16="http://schemas.microsoft.com/office/drawing/2014/main" id="{5B747388-8648-4D85-AC17-8C4451802D94}"/>
+                <a16:creationId xmlns:a16="http://schemas.microsoft.com/office/drawing/2014/main" id="{FD3DB611-79DF-494C-BDBD-BF1F87CAD4B6}"/>
               </a:ext>
             </a:extLst>
           </p:cNvPr>
@@ -5163,7 +5163,7 @@
           <p:cNvPr id="11" name="TextBox 10">
             <a:extLst>
               <a:ext uri="{FF2B5EF4-FFF2-40B4-BE49-F238E27FC236}">
-                <a16:creationId xmlns:a16="http://schemas.microsoft.com/office/drawing/2014/main" id="{69D69D6B-8C73-405C-993F-F824F0B09119}"/>
+                <a16:creationId xmlns:a16="http://schemas.microsoft.com/office/drawing/2014/main" id="{E889D763-A23A-4553-86D0-6A19014772D1}"/>
               </a:ext>
             </a:extLst>
           </p:cNvPr>
@@ -5203,7 +5203,7 @@
           <p:cNvPr id="12" name="TextBox 11">
             <a:extLst>
               <a:ext uri="{FF2B5EF4-FFF2-40B4-BE49-F238E27FC236}">
-                <a16:creationId xmlns:a16="http://schemas.microsoft.com/office/drawing/2014/main" id="{8AC43F49-728A-44F6-9C3D-A035098785FD}"/>
+                <a16:creationId xmlns:a16="http://schemas.microsoft.com/office/drawing/2014/main" id="{7A018C3D-B48A-4606-BB38-A819BFF1DE60}"/>
               </a:ext>
             </a:extLst>
           </p:cNvPr>
@@ -5243,7 +5243,7 @@
           <p:cNvPr id="13" name="TextBox 12">
             <a:extLst>
               <a:ext uri="{FF2B5EF4-FFF2-40B4-BE49-F238E27FC236}">
-                <a16:creationId xmlns:a16="http://schemas.microsoft.com/office/drawing/2014/main" id="{DA25476D-BD0B-4563-85F8-604024DEC8BA}"/>
+                <a16:creationId xmlns:a16="http://schemas.microsoft.com/office/drawing/2014/main" id="{578BDF7F-4C45-43F3-A3AB-9DD4BEE3800D}"/>
               </a:ext>
             </a:extLst>
           </p:cNvPr>
@@ -5283,7 +5283,7 @@
           <p:cNvPr id="14" name="TextBox 13">
             <a:extLst>
               <a:ext uri="{FF2B5EF4-FFF2-40B4-BE49-F238E27FC236}">
-                <a16:creationId xmlns:a16="http://schemas.microsoft.com/office/drawing/2014/main" id="{F471428B-8A93-42AE-8555-47F178F840B3}"/>
+                <a16:creationId xmlns:a16="http://schemas.microsoft.com/office/drawing/2014/main" id="{B08BB4EA-43EE-4511-A903-A8391307550F}"/>
               </a:ext>
             </a:extLst>
           </p:cNvPr>
@@ -5323,7 +5323,7 @@
           <p:cNvPr id="15" name="TextBox 14">
             <a:extLst>
               <a:ext uri="{FF2B5EF4-FFF2-40B4-BE49-F238E27FC236}">
-                <a16:creationId xmlns:a16="http://schemas.microsoft.com/office/drawing/2014/main" id="{F534DFDD-5E9C-43A1-AA76-19045C2DF730}"/>
+                <a16:creationId xmlns:a16="http://schemas.microsoft.com/office/drawing/2014/main" id="{CB1CB4D7-2F8D-46E8-8209-51CFC833762D}"/>
               </a:ext>
             </a:extLst>
           </p:cNvPr>
@@ -5363,7 +5363,7 @@
           <p:cNvPr id="16" name="TextBox 15">
             <a:extLst>
               <a:ext uri="{FF2B5EF4-FFF2-40B4-BE49-F238E27FC236}">
-                <a16:creationId xmlns:a16="http://schemas.microsoft.com/office/drawing/2014/main" id="{E3181472-70C4-41C0-AE3A-D28A53700B1E}"/>
+                <a16:creationId xmlns:a16="http://schemas.microsoft.com/office/drawing/2014/main" id="{FE49000A-DC47-4EE7-A6DE-83BA3A0EEBA8}"/>
               </a:ext>
             </a:extLst>
           </p:cNvPr>
@@ -5401,7 +5401,7 @@
     </p:spTree>
     <p:extLst>
       <p:ext uri="{BB962C8B-B14F-4D97-AF65-F5344CB8AC3E}">
-        <p14:creationId xmlns:p14="http://schemas.microsoft.com/office/powerpoint/2010/main" val="1076897360"/>
+        <p14:creationId xmlns:p14="http://schemas.microsoft.com/office/powerpoint/2010/main" val="1274064544"/>
       </p:ext>
     </p:extLst>
   </p:cSld>

</xml_diff>